<commit_message>
new data + corection jury bloc 1-2
</commit_message>
<xml_diff>
--- a/AIA_Architecte_Intelligence_Artificielle/Bloc_1_Gouvernance_Donnees/Presentation/Bloc1_AIA_Loic_Valentini.pptx
+++ b/AIA_Architecte_Intelligence_Artificielle/Bloc_1_Gouvernance_Donnees/Presentation/Bloc1_AIA_Loic_Valentini.pptx
@@ -9129,7 +9129,7 @@
                 <a:latin typeface="Inter Medium" panose="020B0604020202020204" charset="0"/>
                 <a:ea typeface="Inter Medium" panose="020B0604020202020204" charset="0"/>
               </a:rPr>
-              <a:t>9 principes directeurs</a:t>
+              <a:t>Principes directeurs</a:t>
             </a:r>
             <a:br>
               <a:rPr lang="fr-FR" sz="1400" dirty="0">
@@ -9395,7 +9395,7 @@
           <p:nvPr>
             <p:extLst>
               <p:ext uri="{D42A27DB-BD31-4B8C-83A1-F6EECF244321}">
-                <p14:modId xmlns:p14="http://schemas.microsoft.com/office/powerpoint/2010/main" val="46541507"/>
+                <p14:modId xmlns:p14="http://schemas.microsoft.com/office/powerpoint/2010/main" val="2941742710"/>
               </p:ext>
             </p:extLst>
           </p:nvPr>
@@ -9568,7 +9568,7 @@
                           <a:latin typeface="Inter Medium" panose="020B0604020202020204" charset="0"/>
                           <a:ea typeface="Inter Medium" panose="020B0604020202020204" charset="0"/>
                         </a:rPr>
-                        <a:t>Consentement et traçabilité</a:t>
+                        <a:t>Informations claires et traçabilité</a:t>
                       </a:r>
                     </a:p>
                   </a:txBody>
@@ -10219,7 +10219,7 @@
                           <a:latin typeface="Inter Medium" panose="020B0604020202020204" charset="0"/>
                           <a:ea typeface="Inter Medium" panose="020B0604020202020204" charset="0"/>
                         </a:rPr>
-                        <a:t>Biais, transparence, revue éthique</a:t>
+                        <a:t>Au-delà de la loi : Biais, cas d’usage sensibles, revue éthique</a:t>
                       </a:r>
                     </a:p>
                   </a:txBody>
@@ -10869,11 +10869,11 @@
               </a:rPr>
             </a:br>
             <a:r>
-              <a:rPr lang="fr-FR" sz="1400" b="1" dirty="0" err="1">
-                <a:latin typeface="Inter Medium" panose="020B0604020202020204" charset="0"/>
-                <a:ea typeface="Inter Medium" panose="020B0604020202020204" charset="0"/>
-              </a:rPr>
-              <a:t>Atlation</a:t>
+              <a:rPr lang="fr-FR" sz="1400" b="1">
+                <a:latin typeface="Inter Medium" panose="020B0604020202020204" charset="0"/>
+                <a:ea typeface="Inter Medium" panose="020B0604020202020204" charset="0"/>
+              </a:rPr>
+              <a:t>Alation</a:t>
             </a:r>
             <a:r>
               <a:rPr lang="fr-FR" sz="1400" dirty="0">
@@ -11931,7 +11931,7 @@
           <p:nvPr>
             <p:extLst>
               <p:ext uri="{D42A27DB-BD31-4B8C-83A1-F6EECF244321}">
-                <p14:modId xmlns:p14="http://schemas.microsoft.com/office/powerpoint/2010/main" val="964568513"/>
+                <p14:modId xmlns:p14="http://schemas.microsoft.com/office/powerpoint/2010/main" val="4107104206"/>
               </p:ext>
             </p:extLst>
           </p:nvPr>
@@ -12349,7 +12349,7 @@
                           <a:latin typeface="Inter Medium" panose="020B0604020202020204" charset="0"/>
                           <a:ea typeface="Inter Medium" panose="020B0604020202020204" charset="0"/>
                         </a:rPr>
-                        <a:t>Atlion</a:t>
+                        <a:t>Alation</a:t>
                       </a:r>
                       <a:endParaRPr lang="fr-FR" b="0" cap="none" spc="0" dirty="0">
                         <a:ln w="0"/>

</xml_diff>